<commit_message>
Rebuild Japanese SI project overview deck
</commit_message>
<xml_diff>
--- a/docs/presentation/dist/research-x-presentation.pptx
+++ b/docs/presentation/dist/research-x-presentation.pptx
@@ -14,9 +14,12 @@
     <p:sldId id="262" r:id="rId8"/>
     <p:sldId id="263" r:id="rId9"/>
     <p:sldId id="264" r:id="rId10"/>
+    <p:sldId id="265" r:id="rId11"/>
+    <p:sldId id="266" r:id="rId12"/>
+    <p:sldId id="267" r:id="rId13"/>
   </p:sldIdLst>
   <p:notesMasterIdLst>
-    <p:notesMasterId r:id="rId11"/>
+    <p:notesMasterId r:id="rId14"/>
   </p:notesMasterIdLst>
   <p:sldSz cx="12192000" cy="6858000"/>
   <p:notesSz cx="6858000" cy="12192000"/>
@@ -510,7 +513,7 @@
           <a:p>
             <a:r>
               <a:rPr lang="en-US" dirty="0"/>
-              <a:t>claim: claim-local-x-memory</a:t>
+              <a:t>claim: claim-project-purpose</a:t>
             </a:r>
             <a:endParaRPr lang="en-US" dirty="0"/>
           </a:p>
@@ -552,6 +555,271 @@
 </p:notes>
 </file>
 
+<file path=ppt/notesSlides/notesSlide10.xml><?xml version="1.0" encoding="utf-8"?>
+<p:notes xmlns:a="http://schemas.openxmlformats.org/drawingml/2006/main" xmlns:r="http://schemas.openxmlformats.org/officeDocument/2006/relationships" xmlns:p="http://schemas.openxmlformats.org/presentationml/2006/main">
+  <p:cSld>
+    <p:spTree>
+      <p:nvGrpSpPr>
+        <p:cNvPr id="1" name=""/>
+        <p:cNvGrpSpPr/>
+        <p:nvPr/>
+      </p:nvGrpSpPr>
+      <p:grpSpPr>
+        <a:xfrm>
+          <a:off x="0" y="0"/>
+          <a:ext cx="0" cy="0"/>
+          <a:chOff x="0" y="0"/>
+          <a:chExt cx="0" cy="0"/>
+        </a:xfrm>
+      </p:grpSpPr>
+      <p:sp>
+        <p:nvSpPr>
+          <p:cNvPr id="2" name="Slide Image Placeholder 1"/>
+          <p:cNvSpPr>
+            <a:spLocks noGrp="1" noRot="1" noChangeAspect="1"/>
+          </p:cNvSpPr>
+          <p:nvPr>
+            <p:ph type="sldImg"/>
+          </p:nvPr>
+        </p:nvSpPr>
+        <p:spPr/>
+      </p:sp>
+      <p:sp>
+        <p:nvSpPr>
+          <p:cNvPr id="3" name="Notes Placeholder 2"/>
+          <p:cNvSpPr>
+            <a:spLocks noGrp="1"/>
+          </p:cNvSpPr>
+          <p:nvPr>
+            <p:ph type="body" idx="1"/>
+          </p:nvPr>
+        </p:nvSpPr>
+        <p:spPr/>
+        <p:txBody>
+          <a:bodyPr/>
+          <a:lstStyle/>
+          <a:p>
+            <a:r>
+              <a:rPr lang="en-US" dirty="0"/>
+              <a:t>claim: claim-dev-entrypoints</a:t>
+            </a:r>
+            <a:endParaRPr lang="en-US" dirty="0"/>
+          </a:p>
+        </p:txBody>
+      </p:sp>
+      <p:sp>
+        <p:nvSpPr>
+          <p:cNvPr id="4" name="Slide Number Placeholder 3"/>
+          <p:cNvSpPr>
+            <a:spLocks noGrp="1"/>
+          </p:cNvSpPr>
+          <p:nvPr>
+            <p:ph type="sldNum" sz="quarter" idx="10"/>
+          </p:nvPr>
+        </p:nvSpPr>
+        <p:spPr/>
+        <p:txBody>
+          <a:bodyPr/>
+          <a:lstStyle/>
+          <a:p>
+            <a:fld id="{F7021451-1387-4CA6-816F-3879F97B5CBC}" type="slidenum">
+              <a:rPr lang="en-US"/>
+              <a:t>10</a:t>
+            </a:fld>
+            <a:endParaRPr lang="en-US"/>
+          </a:p>
+        </p:txBody>
+      </p:sp>
+    </p:spTree>
+    <p:extLst>
+      <p:ext uri="{BB962C8B-B14F-4D97-AF65-F5344CB8AC3E}">
+        <p14:creationId xmlns:p14="http://schemas.microsoft.com/office/powerpoint/2010/main" val="1024086991"/>
+      </p:ext>
+    </p:extLst>
+  </p:cSld>
+  <p:clrMapOvr>
+    <a:masterClrMapping/>
+  </p:clrMapOvr>
+</p:notes>
+</file>
+
+<file path=ppt/notesSlides/notesSlide11.xml><?xml version="1.0" encoding="utf-8"?>
+<p:notes xmlns:a="http://schemas.openxmlformats.org/drawingml/2006/main" xmlns:r="http://schemas.openxmlformats.org/officeDocument/2006/relationships" xmlns:p="http://schemas.openxmlformats.org/presentationml/2006/main">
+  <p:cSld>
+    <p:spTree>
+      <p:nvGrpSpPr>
+        <p:cNvPr id="1" name=""/>
+        <p:cNvGrpSpPr/>
+        <p:nvPr/>
+      </p:nvGrpSpPr>
+      <p:grpSpPr>
+        <a:xfrm>
+          <a:off x="0" y="0"/>
+          <a:ext cx="0" cy="0"/>
+          <a:chOff x="0" y="0"/>
+          <a:chExt cx="0" cy="0"/>
+        </a:xfrm>
+      </p:grpSpPr>
+      <p:sp>
+        <p:nvSpPr>
+          <p:cNvPr id="2" name="Slide Image Placeholder 1"/>
+          <p:cNvSpPr>
+            <a:spLocks noGrp="1" noRot="1" noChangeAspect="1"/>
+          </p:cNvSpPr>
+          <p:nvPr>
+            <p:ph type="sldImg"/>
+          </p:nvPr>
+        </p:nvSpPr>
+        <p:spPr/>
+      </p:sp>
+      <p:sp>
+        <p:nvSpPr>
+          <p:cNvPr id="3" name="Notes Placeholder 2"/>
+          <p:cNvSpPr>
+            <a:spLocks noGrp="1"/>
+          </p:cNvSpPr>
+          <p:nvPr>
+            <p:ph type="body" idx="1"/>
+          </p:nvPr>
+        </p:nvSpPr>
+        <p:spPr/>
+        <p:txBody>
+          <a:bodyPr/>
+          <a:lstStyle/>
+          <a:p>
+            <a:r>
+              <a:rPr lang="en-US" dirty="0"/>
+              <a:t>claim: claim-sier-boundary</a:t>
+            </a:r>
+            <a:endParaRPr lang="en-US" dirty="0"/>
+          </a:p>
+        </p:txBody>
+      </p:sp>
+      <p:sp>
+        <p:nvSpPr>
+          <p:cNvPr id="4" name="Slide Number Placeholder 3"/>
+          <p:cNvSpPr>
+            <a:spLocks noGrp="1"/>
+          </p:cNvSpPr>
+          <p:nvPr>
+            <p:ph type="sldNum" sz="quarter" idx="10"/>
+          </p:nvPr>
+        </p:nvSpPr>
+        <p:spPr/>
+        <p:txBody>
+          <a:bodyPr/>
+          <a:lstStyle/>
+          <a:p>
+            <a:fld id="{F7021451-1387-4CA6-816F-3879F97B5CBC}" type="slidenum">
+              <a:rPr lang="en-US"/>
+              <a:t>11</a:t>
+            </a:fld>
+            <a:endParaRPr lang="en-US"/>
+          </a:p>
+        </p:txBody>
+      </p:sp>
+    </p:spTree>
+    <p:extLst>
+      <p:ext uri="{BB962C8B-B14F-4D97-AF65-F5344CB8AC3E}">
+        <p14:creationId xmlns:p14="http://schemas.microsoft.com/office/powerpoint/2010/main" val="1024086991"/>
+      </p:ext>
+    </p:extLst>
+  </p:cSld>
+  <p:clrMapOvr>
+    <a:masterClrMapping/>
+  </p:clrMapOvr>
+</p:notes>
+</file>
+
+<file path=ppt/notesSlides/notesSlide12.xml><?xml version="1.0" encoding="utf-8"?>
+<p:notes xmlns:a="http://schemas.openxmlformats.org/drawingml/2006/main" xmlns:r="http://schemas.openxmlformats.org/officeDocument/2006/relationships" xmlns:p="http://schemas.openxmlformats.org/presentationml/2006/main">
+  <p:cSld>
+    <p:spTree>
+      <p:nvGrpSpPr>
+        <p:cNvPr id="1" name=""/>
+        <p:cNvGrpSpPr/>
+        <p:nvPr/>
+      </p:nvGrpSpPr>
+      <p:grpSpPr>
+        <a:xfrm>
+          <a:off x="0" y="0"/>
+          <a:ext cx="0" cy="0"/>
+          <a:chOff x="0" y="0"/>
+          <a:chExt cx="0" cy="0"/>
+        </a:xfrm>
+      </p:grpSpPr>
+      <p:sp>
+        <p:nvSpPr>
+          <p:cNvPr id="2" name="Slide Image Placeholder 1"/>
+          <p:cNvSpPr>
+            <a:spLocks noGrp="1" noRot="1" noChangeAspect="1"/>
+          </p:cNvSpPr>
+          <p:nvPr>
+            <p:ph type="sldImg"/>
+          </p:nvPr>
+        </p:nvSpPr>
+        <p:spPr/>
+      </p:sp>
+      <p:sp>
+        <p:nvSpPr>
+          <p:cNvPr id="3" name="Notes Placeholder 2"/>
+          <p:cNvSpPr>
+            <a:spLocks noGrp="1"/>
+          </p:cNvSpPr>
+          <p:nvPr>
+            <p:ph type="body" idx="1"/>
+          </p:nvPr>
+        </p:nvSpPr>
+        <p:spPr/>
+        <p:txBody>
+          <a:bodyPr/>
+          <a:lstStyle/>
+          <a:p>
+            <a:r>
+              <a:rPr lang="en-US" dirty="0"/>
+              <a:t>claim: claim-current-open-items
+claim: claim-control-artifacts</a:t>
+            </a:r>
+            <a:endParaRPr lang="en-US" dirty="0"/>
+          </a:p>
+        </p:txBody>
+      </p:sp>
+      <p:sp>
+        <p:nvSpPr>
+          <p:cNvPr id="4" name="Slide Number Placeholder 3"/>
+          <p:cNvSpPr>
+            <a:spLocks noGrp="1"/>
+          </p:cNvSpPr>
+          <p:nvPr>
+            <p:ph type="sldNum" sz="quarter" idx="10"/>
+          </p:nvPr>
+        </p:nvSpPr>
+        <p:spPr/>
+        <p:txBody>
+          <a:bodyPr/>
+          <a:lstStyle/>
+          <a:p>
+            <a:fld id="{F7021451-1387-4CA6-816F-3879F97B5CBC}" type="slidenum">
+              <a:rPr lang="en-US"/>
+              <a:t>12</a:t>
+            </a:fld>
+            <a:endParaRPr lang="en-US"/>
+          </a:p>
+        </p:txBody>
+      </p:sp>
+    </p:spTree>
+    <p:extLst>
+      <p:ext uri="{BB962C8B-B14F-4D97-AF65-F5344CB8AC3E}">
+        <p14:creationId xmlns:p14="http://schemas.microsoft.com/office/powerpoint/2010/main" val="1024086991"/>
+      </p:ext>
+    </p:extLst>
+  </p:cSld>
+  <p:clrMapOvr>
+    <a:masterClrMapping/>
+  </p:clrMapOvr>
+</p:notes>
+</file>
+
 <file path=ppt/notesSlides/notesSlide2.xml><?xml version="1.0" encoding="utf-8"?>
 <p:notes xmlns:a="http://schemas.openxmlformats.org/drawingml/2006/main" xmlns:r="http://schemas.openxmlformats.org/officeDocument/2006/relationships" xmlns:p="http://schemas.openxmlformats.org/presentationml/2006/main">
   <p:cSld>
@@ -598,7 +866,7 @@
           <a:p>
             <a:r>
               <a:rPr lang="en-US" dirty="0"/>
-              <a:t>claim: claim-search-results-are-candidates</a:t>
+              <a:t>claim: claim-sier-context</a:t>
             </a:r>
             <a:endParaRPr lang="en-US" dirty="0"/>
           </a:p>
@@ -686,7 +954,7 @@
           <a:p>
             <a:r>
               <a:rPr lang="en-US" dirty="0"/>
-              <a:t>claim: claim-evidence-first</a:t>
+              <a:t>claim: claim-runtime-architecture</a:t>
             </a:r>
             <a:endParaRPr lang="en-US" dirty="0"/>
           </a:p>
@@ -774,7 +1042,7 @@
           <a:p>
             <a:r>
               <a:rPr lang="en-US" dirty="0"/>
-              <a:t>claim: claim-cli-entrypoint</a:t>
+              <a:t>claim: claim-acquisition-chain</a:t>
             </a:r>
             <a:endParaRPr lang="en-US" dirty="0"/>
           </a:p>
@@ -862,7 +1130,7 @@
           <a:p>
             <a:r>
               <a:rPr lang="en-US" dirty="0"/>
-              <a:t>claim: claim-provider-gated</a:t>
+              <a:t>claim: claim-bookmark-store</a:t>
             </a:r>
             <a:endParaRPr lang="en-US" dirty="0"/>
           </a:p>
@@ -950,7 +1218,7 @@
           <a:p>
             <a:r>
               <a:rPr lang="en-US" dirty="0"/>
-              <a:t>claim: claim-memory-schema</a:t>
+              <a:t>claim: claim-evidence-invariant</a:t>
             </a:r>
             <a:endParaRPr lang="en-US" dirty="0"/>
           </a:p>
@@ -1038,7 +1306,7 @@
           <a:p>
             <a:r>
               <a:rPr lang="en-US" dirty="0"/>
-              <a:t>claim: claim-presentation-stage-boundary</a:t>
+              <a:t>claim: claim-memory-schema</a:t>
             </a:r>
             <a:endParaRPr lang="en-US" dirty="0"/>
           </a:p>
@@ -1126,7 +1394,7 @@
           <a:p>
             <a:r>
               <a:rPr lang="en-US" dirty="0"/>
-              <a:t>claim: claim-generated-artifacts-not-evidence</a:t>
+              <a:t>claim: claim-workflow-execution</a:t>
             </a:r>
             <a:endParaRPr lang="en-US" dirty="0"/>
           </a:p>
@@ -1214,7 +1482,7 @@
           <a:p>
             <a:r>
               <a:rPr lang="en-US" dirty="0"/>
-              <a:t/>
+              <a:t>claim: claim-provider-gate</a:t>
             </a:r>
             <a:endParaRPr lang="en-US" dirty="0"/>
           </a:p>
@@ -1566,6 +1834,123 @@
 <file path=ppt/slides/slide1.xml><?xml version="1.0" encoding="utf-8"?>
 <p:sld xmlns:a="http://schemas.openxmlformats.org/drawingml/2006/main" xmlns:r="http://schemas.openxmlformats.org/officeDocument/2006/relationships" xmlns:p="http://schemas.openxmlformats.org/presentationml/2006/main">
   <p:cSld name="Slide 1">
+    <p:bg>
+      <p:bgPr>
+        <a:blipFill dpi="0" rotWithShape="1">
+          <a:blip r:embed="rId1">
+            <a:lum/>
+          </a:blip>
+          <a:srcRect/>
+          <a:stretch>
+            <a:fillRect/>
+          </a:stretch>
+        </a:blipFill>
+        <a:effectLst/>
+      </p:bgPr>
+    </p:bg>
+    <p:spTree>
+      <p:nvGrpSpPr>
+        <p:cNvPr id="1" name=""/>
+        <p:cNvGrpSpPr/>
+        <p:nvPr/>
+      </p:nvGrpSpPr>
+      <p:grpSpPr>
+        <a:xfrm>
+          <a:off x="0" y="0"/>
+          <a:ext cx="0" cy="0"/>
+          <a:chOff x="0" y="0"/>
+          <a:chExt cx="0" cy="0"/>
+        </a:xfrm>
+      </p:grpSpPr>
+    </p:spTree>
+  </p:cSld>
+  <p:clrMapOvr>
+    <a:masterClrMapping/>
+  </p:clrMapOvr>
+</p:sld>
+</file>
+
+<file path=ppt/slides/slide10.xml><?xml version="1.0" encoding="utf-8"?>
+<p:sld xmlns:a="http://schemas.openxmlformats.org/drawingml/2006/main" xmlns:r="http://schemas.openxmlformats.org/officeDocument/2006/relationships" xmlns:p="http://schemas.openxmlformats.org/presentationml/2006/main">
+  <p:cSld name="Slide 10">
+    <p:bg>
+      <p:bgPr>
+        <a:blipFill dpi="0" rotWithShape="1">
+          <a:blip r:embed="rId1">
+            <a:lum/>
+          </a:blip>
+          <a:srcRect/>
+          <a:stretch>
+            <a:fillRect/>
+          </a:stretch>
+        </a:blipFill>
+        <a:effectLst/>
+      </p:bgPr>
+    </p:bg>
+    <p:spTree>
+      <p:nvGrpSpPr>
+        <p:cNvPr id="1" name=""/>
+        <p:cNvGrpSpPr/>
+        <p:nvPr/>
+      </p:nvGrpSpPr>
+      <p:grpSpPr>
+        <a:xfrm>
+          <a:off x="0" y="0"/>
+          <a:ext cx="0" cy="0"/>
+          <a:chOff x="0" y="0"/>
+          <a:chExt cx="0" cy="0"/>
+        </a:xfrm>
+      </p:grpSpPr>
+    </p:spTree>
+  </p:cSld>
+  <p:clrMapOvr>
+    <a:masterClrMapping/>
+  </p:clrMapOvr>
+</p:sld>
+</file>
+
+<file path=ppt/slides/slide11.xml><?xml version="1.0" encoding="utf-8"?>
+<p:sld xmlns:a="http://schemas.openxmlformats.org/drawingml/2006/main" xmlns:r="http://schemas.openxmlformats.org/officeDocument/2006/relationships" xmlns:p="http://schemas.openxmlformats.org/presentationml/2006/main">
+  <p:cSld name="Slide 11">
+    <p:bg>
+      <p:bgPr>
+        <a:blipFill dpi="0" rotWithShape="1">
+          <a:blip r:embed="rId1">
+            <a:lum/>
+          </a:blip>
+          <a:srcRect/>
+          <a:stretch>
+            <a:fillRect/>
+          </a:stretch>
+        </a:blipFill>
+        <a:effectLst/>
+      </p:bgPr>
+    </p:bg>
+    <p:spTree>
+      <p:nvGrpSpPr>
+        <p:cNvPr id="1" name=""/>
+        <p:cNvGrpSpPr/>
+        <p:nvPr/>
+      </p:nvGrpSpPr>
+      <p:grpSpPr>
+        <a:xfrm>
+          <a:off x="0" y="0"/>
+          <a:ext cx="0" cy="0"/>
+          <a:chOff x="0" y="0"/>
+          <a:chExt cx="0" cy="0"/>
+        </a:xfrm>
+      </p:grpSpPr>
+    </p:spTree>
+  </p:cSld>
+  <p:clrMapOvr>
+    <a:masterClrMapping/>
+  </p:clrMapOvr>
+</p:sld>
+</file>
+
+<file path=ppt/slides/slide12.xml><?xml version="1.0" encoding="utf-8"?>
+<p:sld xmlns:a="http://schemas.openxmlformats.org/drawingml/2006/main" xmlns:r="http://schemas.openxmlformats.org/officeDocument/2006/relationships" xmlns:p="http://schemas.openxmlformats.org/presentationml/2006/main">
+  <p:cSld name="Slide 12">
     <p:bg>
       <p:bgPr>
         <a:blipFill dpi="0" rotWithShape="1">

</xml_diff>

<commit_message>
Add C4 context and container views to presentation
</commit_message>
<xml_diff>
--- a/docs/presentation/dist/research-x-presentation.pptx
+++ b/docs/presentation/dist/research-x-presentation.pptx
@@ -601,7 +601,7 @@
           <a:p>
             <a:r>
               <a:rPr lang="en-US" dirty="0"/>
-              <a:t>claim: claim-dev-entrypoints</a:t>
+              <a:t>claim: claim-provider-gate</a:t>
             </a:r>
             <a:endParaRPr lang="en-US" dirty="0"/>
           </a:p>
@@ -689,7 +689,8 @@
           <a:p>
             <a:r>
               <a:rPr lang="en-US" dirty="0"/>
-              <a:t>claim: claim-sier-boundary</a:t>
+              <a:t>claim: claim-dev-entrypoints
+claim: claim-sier-boundary</a:t>
             </a:r>
             <a:endParaRPr lang="en-US" dirty="0"/>
           </a:p>
@@ -1042,7 +1043,7 @@
           <a:p>
             <a:r>
               <a:rPr lang="en-US" dirty="0"/>
-              <a:t>claim: claim-acquisition-chain</a:t>
+              <a:t>claim: claim-c4-container-boundary</a:t>
             </a:r>
             <a:endParaRPr lang="en-US" dirty="0"/>
           </a:p>
@@ -1130,7 +1131,7 @@
           <a:p>
             <a:r>
               <a:rPr lang="en-US" dirty="0"/>
-              <a:t>claim: claim-bookmark-store</a:t>
+              <a:t>claim: claim-acquisition-chain</a:t>
             </a:r>
             <a:endParaRPr lang="en-US" dirty="0"/>
           </a:p>
@@ -1218,7 +1219,7 @@
           <a:p>
             <a:r>
               <a:rPr lang="en-US" dirty="0"/>
-              <a:t>claim: claim-evidence-invariant</a:t>
+              <a:t>claim: claim-bookmark-store</a:t>
             </a:r>
             <a:endParaRPr lang="en-US" dirty="0"/>
           </a:p>
@@ -1306,7 +1307,7 @@
           <a:p>
             <a:r>
               <a:rPr lang="en-US" dirty="0"/>
-              <a:t>claim: claim-memory-schema</a:t>
+              <a:t>claim: claim-evidence-invariant</a:t>
             </a:r>
             <a:endParaRPr lang="en-US" dirty="0"/>
           </a:p>
@@ -1394,7 +1395,7 @@
           <a:p>
             <a:r>
               <a:rPr lang="en-US" dirty="0"/>
-              <a:t>claim: claim-workflow-execution</a:t>
+              <a:t>claim: claim-memory-schema</a:t>
             </a:r>
             <a:endParaRPr lang="en-US" dirty="0"/>
           </a:p>
@@ -1482,7 +1483,7 @@
           <a:p>
             <a:r>
               <a:rPr lang="en-US" dirty="0"/>
-              <a:t>claim: claim-provider-gate</a:t>
+              <a:t>claim: claim-workflow-execution</a:t>
             </a:r>
             <a:endParaRPr lang="en-US" dirty="0"/>
           </a:p>

</xml_diff>

<commit_message>
Improve presentation diagrams for human review
</commit_message>
<xml_diff>
--- a/docs/presentation/dist/research-x-presentation.pptx
+++ b/docs/presentation/dist/research-x-presentation.pptx
@@ -12,14 +12,9 @@
     <p:sldId id="260" r:id="rId6"/>
     <p:sldId id="261" r:id="rId7"/>
     <p:sldId id="262" r:id="rId8"/>
-    <p:sldId id="263" r:id="rId9"/>
-    <p:sldId id="264" r:id="rId10"/>
-    <p:sldId id="265" r:id="rId11"/>
-    <p:sldId id="266" r:id="rId12"/>
-    <p:sldId id="267" r:id="rId13"/>
   </p:sldIdLst>
   <p:notesMasterIdLst>
-    <p:notesMasterId r:id="rId14"/>
+    <p:notesMasterId r:id="rId9"/>
   </p:notesMasterIdLst>
   <p:sldSz cx="12192000" cy="6858000"/>
   <p:notesSz cx="6858000" cy="12192000"/>
@@ -513,7 +508,8 @@
           <a:p>
             <a:r>
               <a:rPr lang="en-US" dirty="0"/>
-              <a:t>claim: claim-project-purpose</a:t>
+              <a:t>claim: claim-project-purpose
+claim: claim-sier-context</a:t>
             </a:r>
             <a:endParaRPr lang="en-US" dirty="0"/>
           </a:p>
@@ -537,272 +533,6 @@
             <a:fld id="{F7021451-1387-4CA6-816F-3879F97B5CBC}" type="slidenum">
               <a:rPr lang="en-US"/>
               <a:t>1</a:t>
-            </a:fld>
-            <a:endParaRPr lang="en-US"/>
-          </a:p>
-        </p:txBody>
-      </p:sp>
-    </p:spTree>
-    <p:extLst>
-      <p:ext uri="{BB962C8B-B14F-4D97-AF65-F5344CB8AC3E}">
-        <p14:creationId xmlns:p14="http://schemas.microsoft.com/office/powerpoint/2010/main" val="1024086991"/>
-      </p:ext>
-    </p:extLst>
-  </p:cSld>
-  <p:clrMapOvr>
-    <a:masterClrMapping/>
-  </p:clrMapOvr>
-</p:notes>
-</file>
-
-<file path=ppt/notesSlides/notesSlide10.xml><?xml version="1.0" encoding="utf-8"?>
-<p:notes xmlns:a="http://schemas.openxmlformats.org/drawingml/2006/main" xmlns:r="http://schemas.openxmlformats.org/officeDocument/2006/relationships" xmlns:p="http://schemas.openxmlformats.org/presentationml/2006/main">
-  <p:cSld>
-    <p:spTree>
-      <p:nvGrpSpPr>
-        <p:cNvPr id="1" name=""/>
-        <p:cNvGrpSpPr/>
-        <p:nvPr/>
-      </p:nvGrpSpPr>
-      <p:grpSpPr>
-        <a:xfrm>
-          <a:off x="0" y="0"/>
-          <a:ext cx="0" cy="0"/>
-          <a:chOff x="0" y="0"/>
-          <a:chExt cx="0" cy="0"/>
-        </a:xfrm>
-      </p:grpSpPr>
-      <p:sp>
-        <p:nvSpPr>
-          <p:cNvPr id="2" name="Slide Image Placeholder 1"/>
-          <p:cNvSpPr>
-            <a:spLocks noGrp="1" noRot="1" noChangeAspect="1"/>
-          </p:cNvSpPr>
-          <p:nvPr>
-            <p:ph type="sldImg"/>
-          </p:nvPr>
-        </p:nvSpPr>
-        <p:spPr/>
-      </p:sp>
-      <p:sp>
-        <p:nvSpPr>
-          <p:cNvPr id="3" name="Notes Placeholder 2"/>
-          <p:cNvSpPr>
-            <a:spLocks noGrp="1"/>
-          </p:cNvSpPr>
-          <p:nvPr>
-            <p:ph type="body" idx="1"/>
-          </p:nvPr>
-        </p:nvSpPr>
-        <p:spPr/>
-        <p:txBody>
-          <a:bodyPr/>
-          <a:lstStyle/>
-          <a:p>
-            <a:r>
-              <a:rPr lang="en-US" dirty="0"/>
-              <a:t>claim: claim-provider-gate</a:t>
-            </a:r>
-            <a:endParaRPr lang="en-US" dirty="0"/>
-          </a:p>
-        </p:txBody>
-      </p:sp>
-      <p:sp>
-        <p:nvSpPr>
-          <p:cNvPr id="4" name="Slide Number Placeholder 3"/>
-          <p:cNvSpPr>
-            <a:spLocks noGrp="1"/>
-          </p:cNvSpPr>
-          <p:nvPr>
-            <p:ph type="sldNum" sz="quarter" idx="10"/>
-          </p:nvPr>
-        </p:nvSpPr>
-        <p:spPr/>
-        <p:txBody>
-          <a:bodyPr/>
-          <a:lstStyle/>
-          <a:p>
-            <a:fld id="{F7021451-1387-4CA6-816F-3879F97B5CBC}" type="slidenum">
-              <a:rPr lang="en-US"/>
-              <a:t>10</a:t>
-            </a:fld>
-            <a:endParaRPr lang="en-US"/>
-          </a:p>
-        </p:txBody>
-      </p:sp>
-    </p:spTree>
-    <p:extLst>
-      <p:ext uri="{BB962C8B-B14F-4D97-AF65-F5344CB8AC3E}">
-        <p14:creationId xmlns:p14="http://schemas.microsoft.com/office/powerpoint/2010/main" val="1024086991"/>
-      </p:ext>
-    </p:extLst>
-  </p:cSld>
-  <p:clrMapOvr>
-    <a:masterClrMapping/>
-  </p:clrMapOvr>
-</p:notes>
-</file>
-
-<file path=ppt/notesSlides/notesSlide11.xml><?xml version="1.0" encoding="utf-8"?>
-<p:notes xmlns:a="http://schemas.openxmlformats.org/drawingml/2006/main" xmlns:r="http://schemas.openxmlformats.org/officeDocument/2006/relationships" xmlns:p="http://schemas.openxmlformats.org/presentationml/2006/main">
-  <p:cSld>
-    <p:spTree>
-      <p:nvGrpSpPr>
-        <p:cNvPr id="1" name=""/>
-        <p:cNvGrpSpPr/>
-        <p:nvPr/>
-      </p:nvGrpSpPr>
-      <p:grpSpPr>
-        <a:xfrm>
-          <a:off x="0" y="0"/>
-          <a:ext cx="0" cy="0"/>
-          <a:chOff x="0" y="0"/>
-          <a:chExt cx="0" cy="0"/>
-        </a:xfrm>
-      </p:grpSpPr>
-      <p:sp>
-        <p:nvSpPr>
-          <p:cNvPr id="2" name="Slide Image Placeholder 1"/>
-          <p:cNvSpPr>
-            <a:spLocks noGrp="1" noRot="1" noChangeAspect="1"/>
-          </p:cNvSpPr>
-          <p:nvPr>
-            <p:ph type="sldImg"/>
-          </p:nvPr>
-        </p:nvSpPr>
-        <p:spPr/>
-      </p:sp>
-      <p:sp>
-        <p:nvSpPr>
-          <p:cNvPr id="3" name="Notes Placeholder 2"/>
-          <p:cNvSpPr>
-            <a:spLocks noGrp="1"/>
-          </p:cNvSpPr>
-          <p:nvPr>
-            <p:ph type="body" idx="1"/>
-          </p:nvPr>
-        </p:nvSpPr>
-        <p:spPr/>
-        <p:txBody>
-          <a:bodyPr/>
-          <a:lstStyle/>
-          <a:p>
-            <a:r>
-              <a:rPr lang="en-US" dirty="0"/>
-              <a:t>claim: claim-dev-entrypoints
-claim: claim-sier-boundary</a:t>
-            </a:r>
-            <a:endParaRPr lang="en-US" dirty="0"/>
-          </a:p>
-        </p:txBody>
-      </p:sp>
-      <p:sp>
-        <p:nvSpPr>
-          <p:cNvPr id="4" name="Slide Number Placeholder 3"/>
-          <p:cNvSpPr>
-            <a:spLocks noGrp="1"/>
-          </p:cNvSpPr>
-          <p:nvPr>
-            <p:ph type="sldNum" sz="quarter" idx="10"/>
-          </p:nvPr>
-        </p:nvSpPr>
-        <p:spPr/>
-        <p:txBody>
-          <a:bodyPr/>
-          <a:lstStyle/>
-          <a:p>
-            <a:fld id="{F7021451-1387-4CA6-816F-3879F97B5CBC}" type="slidenum">
-              <a:rPr lang="en-US"/>
-              <a:t>11</a:t>
-            </a:fld>
-            <a:endParaRPr lang="en-US"/>
-          </a:p>
-        </p:txBody>
-      </p:sp>
-    </p:spTree>
-    <p:extLst>
-      <p:ext uri="{BB962C8B-B14F-4D97-AF65-F5344CB8AC3E}">
-        <p14:creationId xmlns:p14="http://schemas.microsoft.com/office/powerpoint/2010/main" val="1024086991"/>
-      </p:ext>
-    </p:extLst>
-  </p:cSld>
-  <p:clrMapOvr>
-    <a:masterClrMapping/>
-  </p:clrMapOvr>
-</p:notes>
-</file>
-
-<file path=ppt/notesSlides/notesSlide12.xml><?xml version="1.0" encoding="utf-8"?>
-<p:notes xmlns:a="http://schemas.openxmlformats.org/drawingml/2006/main" xmlns:r="http://schemas.openxmlformats.org/officeDocument/2006/relationships" xmlns:p="http://schemas.openxmlformats.org/presentationml/2006/main">
-  <p:cSld>
-    <p:spTree>
-      <p:nvGrpSpPr>
-        <p:cNvPr id="1" name=""/>
-        <p:cNvGrpSpPr/>
-        <p:nvPr/>
-      </p:nvGrpSpPr>
-      <p:grpSpPr>
-        <a:xfrm>
-          <a:off x="0" y="0"/>
-          <a:ext cx="0" cy="0"/>
-          <a:chOff x="0" y="0"/>
-          <a:chExt cx="0" cy="0"/>
-        </a:xfrm>
-      </p:grpSpPr>
-      <p:sp>
-        <p:nvSpPr>
-          <p:cNvPr id="2" name="Slide Image Placeholder 1"/>
-          <p:cNvSpPr>
-            <a:spLocks noGrp="1" noRot="1" noChangeAspect="1"/>
-          </p:cNvSpPr>
-          <p:nvPr>
-            <p:ph type="sldImg"/>
-          </p:nvPr>
-        </p:nvSpPr>
-        <p:spPr/>
-      </p:sp>
-      <p:sp>
-        <p:nvSpPr>
-          <p:cNvPr id="3" name="Notes Placeholder 2"/>
-          <p:cNvSpPr>
-            <a:spLocks noGrp="1"/>
-          </p:cNvSpPr>
-          <p:nvPr>
-            <p:ph type="body" idx="1"/>
-          </p:nvPr>
-        </p:nvSpPr>
-        <p:spPr/>
-        <p:txBody>
-          <a:bodyPr/>
-          <a:lstStyle/>
-          <a:p>
-            <a:r>
-              <a:rPr lang="en-US" dirty="0"/>
-              <a:t>claim: claim-current-open-items
-claim: claim-control-artifacts</a:t>
-            </a:r>
-            <a:endParaRPr lang="en-US" dirty="0"/>
-          </a:p>
-        </p:txBody>
-      </p:sp>
-      <p:sp>
-        <p:nvSpPr>
-          <p:cNvPr id="4" name="Slide Number Placeholder 3"/>
-          <p:cNvSpPr>
-            <a:spLocks noGrp="1"/>
-          </p:cNvSpPr>
-          <p:nvPr>
-            <p:ph type="sldNum" sz="quarter" idx="10"/>
-          </p:nvPr>
-        </p:nvSpPr>
-        <p:spPr/>
-        <p:txBody>
-          <a:bodyPr/>
-          <a:lstStyle/>
-          <a:p>
-            <a:fld id="{F7021451-1387-4CA6-816F-3879F97B5CBC}" type="slidenum">
-              <a:rPr lang="en-US"/>
-              <a:t>12</a:t>
             </a:fld>
             <a:endParaRPr lang="en-US"/>
           </a:p>
@@ -867,7 +597,10 @@
           <a:p>
             <a:r>
               <a:rPr lang="en-US" dirty="0"/>
-              <a:t>claim: claim-sier-context</a:t>
+              <a:t>claim: claim-runtime-architecture
+claim: claim-c4-container-boundary
+claim: claim-acquisition-chain
+claim: claim-bookmark-store</a:t>
             </a:r>
             <a:endParaRPr lang="en-US" dirty="0"/>
           </a:p>
@@ -955,7 +688,8 @@
           <a:p>
             <a:r>
               <a:rPr lang="en-US" dirty="0"/>
-              <a:t>claim: claim-runtime-architecture</a:t>
+              <a:t>claim: claim-evidence-invariant
+claim: claim-memory-schema</a:t>
             </a:r>
             <a:endParaRPr lang="en-US" dirty="0"/>
           </a:p>
@@ -1043,7 +777,7 @@
           <a:p>
             <a:r>
               <a:rPr lang="en-US" dirty="0"/>
-              <a:t>claim: claim-c4-container-boundary</a:t>
+              <a:t>claim: claim-workflow-execution</a:t>
             </a:r>
             <a:endParaRPr lang="en-US" dirty="0"/>
           </a:p>
@@ -1131,7 +865,8 @@
           <a:p>
             <a:r>
               <a:rPr lang="en-US" dirty="0"/>
-              <a:t>claim: claim-acquisition-chain</a:t>
+              <a:t>claim: claim-provider-gate
+claim: claim-sier-boundary</a:t>
             </a:r>
             <a:endParaRPr lang="en-US" dirty="0"/>
           </a:p>
@@ -1219,7 +954,8 @@
           <a:p>
             <a:r>
               <a:rPr lang="en-US" dirty="0"/>
-              <a:t>claim: claim-bookmark-store</a:t>
+              <a:t>claim: claim-current-open-items
+claim: claim-control-artifacts</a:t>
             </a:r>
             <a:endParaRPr lang="en-US" dirty="0"/>
           </a:p>
@@ -1307,7 +1043,7 @@
           <a:p>
             <a:r>
               <a:rPr lang="en-US" dirty="0"/>
-              <a:t>claim: claim-evidence-invariant</a:t>
+              <a:t>claim: claim-dev-entrypoints</a:t>
             </a:r>
             <a:endParaRPr lang="en-US" dirty="0"/>
           </a:p>
@@ -1331,182 +1067,6 @@
             <a:fld id="{F7021451-1387-4CA6-816F-3879F97B5CBC}" type="slidenum">
               <a:rPr lang="en-US"/>
               <a:t>7</a:t>
-            </a:fld>
-            <a:endParaRPr lang="en-US"/>
-          </a:p>
-        </p:txBody>
-      </p:sp>
-    </p:spTree>
-    <p:extLst>
-      <p:ext uri="{BB962C8B-B14F-4D97-AF65-F5344CB8AC3E}">
-        <p14:creationId xmlns:p14="http://schemas.microsoft.com/office/powerpoint/2010/main" val="1024086991"/>
-      </p:ext>
-    </p:extLst>
-  </p:cSld>
-  <p:clrMapOvr>
-    <a:masterClrMapping/>
-  </p:clrMapOvr>
-</p:notes>
-</file>
-
-<file path=ppt/notesSlides/notesSlide8.xml><?xml version="1.0" encoding="utf-8"?>
-<p:notes xmlns:a="http://schemas.openxmlformats.org/drawingml/2006/main" xmlns:r="http://schemas.openxmlformats.org/officeDocument/2006/relationships" xmlns:p="http://schemas.openxmlformats.org/presentationml/2006/main">
-  <p:cSld>
-    <p:spTree>
-      <p:nvGrpSpPr>
-        <p:cNvPr id="1" name=""/>
-        <p:cNvGrpSpPr/>
-        <p:nvPr/>
-      </p:nvGrpSpPr>
-      <p:grpSpPr>
-        <a:xfrm>
-          <a:off x="0" y="0"/>
-          <a:ext cx="0" cy="0"/>
-          <a:chOff x="0" y="0"/>
-          <a:chExt cx="0" cy="0"/>
-        </a:xfrm>
-      </p:grpSpPr>
-      <p:sp>
-        <p:nvSpPr>
-          <p:cNvPr id="2" name="Slide Image Placeholder 1"/>
-          <p:cNvSpPr>
-            <a:spLocks noGrp="1" noRot="1" noChangeAspect="1"/>
-          </p:cNvSpPr>
-          <p:nvPr>
-            <p:ph type="sldImg"/>
-          </p:nvPr>
-        </p:nvSpPr>
-        <p:spPr/>
-      </p:sp>
-      <p:sp>
-        <p:nvSpPr>
-          <p:cNvPr id="3" name="Notes Placeholder 2"/>
-          <p:cNvSpPr>
-            <a:spLocks noGrp="1"/>
-          </p:cNvSpPr>
-          <p:nvPr>
-            <p:ph type="body" idx="1"/>
-          </p:nvPr>
-        </p:nvSpPr>
-        <p:spPr/>
-        <p:txBody>
-          <a:bodyPr/>
-          <a:lstStyle/>
-          <a:p>
-            <a:r>
-              <a:rPr lang="en-US" dirty="0"/>
-              <a:t>claim: claim-memory-schema</a:t>
-            </a:r>
-            <a:endParaRPr lang="en-US" dirty="0"/>
-          </a:p>
-        </p:txBody>
-      </p:sp>
-      <p:sp>
-        <p:nvSpPr>
-          <p:cNvPr id="4" name="Slide Number Placeholder 3"/>
-          <p:cNvSpPr>
-            <a:spLocks noGrp="1"/>
-          </p:cNvSpPr>
-          <p:nvPr>
-            <p:ph type="sldNum" sz="quarter" idx="10"/>
-          </p:nvPr>
-        </p:nvSpPr>
-        <p:spPr/>
-        <p:txBody>
-          <a:bodyPr/>
-          <a:lstStyle/>
-          <a:p>
-            <a:fld id="{F7021451-1387-4CA6-816F-3879F97B5CBC}" type="slidenum">
-              <a:rPr lang="en-US"/>
-              <a:t>8</a:t>
-            </a:fld>
-            <a:endParaRPr lang="en-US"/>
-          </a:p>
-        </p:txBody>
-      </p:sp>
-    </p:spTree>
-    <p:extLst>
-      <p:ext uri="{BB962C8B-B14F-4D97-AF65-F5344CB8AC3E}">
-        <p14:creationId xmlns:p14="http://schemas.microsoft.com/office/powerpoint/2010/main" val="1024086991"/>
-      </p:ext>
-    </p:extLst>
-  </p:cSld>
-  <p:clrMapOvr>
-    <a:masterClrMapping/>
-  </p:clrMapOvr>
-</p:notes>
-</file>
-
-<file path=ppt/notesSlides/notesSlide9.xml><?xml version="1.0" encoding="utf-8"?>
-<p:notes xmlns:a="http://schemas.openxmlformats.org/drawingml/2006/main" xmlns:r="http://schemas.openxmlformats.org/officeDocument/2006/relationships" xmlns:p="http://schemas.openxmlformats.org/presentationml/2006/main">
-  <p:cSld>
-    <p:spTree>
-      <p:nvGrpSpPr>
-        <p:cNvPr id="1" name=""/>
-        <p:cNvGrpSpPr/>
-        <p:nvPr/>
-      </p:nvGrpSpPr>
-      <p:grpSpPr>
-        <a:xfrm>
-          <a:off x="0" y="0"/>
-          <a:ext cx="0" cy="0"/>
-          <a:chOff x="0" y="0"/>
-          <a:chExt cx="0" cy="0"/>
-        </a:xfrm>
-      </p:grpSpPr>
-      <p:sp>
-        <p:nvSpPr>
-          <p:cNvPr id="2" name="Slide Image Placeholder 1"/>
-          <p:cNvSpPr>
-            <a:spLocks noGrp="1" noRot="1" noChangeAspect="1"/>
-          </p:cNvSpPr>
-          <p:nvPr>
-            <p:ph type="sldImg"/>
-          </p:nvPr>
-        </p:nvSpPr>
-        <p:spPr/>
-      </p:sp>
-      <p:sp>
-        <p:nvSpPr>
-          <p:cNvPr id="3" name="Notes Placeholder 2"/>
-          <p:cNvSpPr>
-            <a:spLocks noGrp="1"/>
-          </p:cNvSpPr>
-          <p:nvPr>
-            <p:ph type="body" idx="1"/>
-          </p:nvPr>
-        </p:nvSpPr>
-        <p:spPr/>
-        <p:txBody>
-          <a:bodyPr/>
-          <a:lstStyle/>
-          <a:p>
-            <a:r>
-              <a:rPr lang="en-US" dirty="0"/>
-              <a:t>claim: claim-workflow-execution</a:t>
-            </a:r>
-            <a:endParaRPr lang="en-US" dirty="0"/>
-          </a:p>
-        </p:txBody>
-      </p:sp>
-      <p:sp>
-        <p:nvSpPr>
-          <p:cNvPr id="4" name="Slide Number Placeholder 3"/>
-          <p:cNvSpPr>
-            <a:spLocks noGrp="1"/>
-          </p:cNvSpPr>
-          <p:nvPr>
-            <p:ph type="sldNum" sz="quarter" idx="10"/>
-          </p:nvPr>
-        </p:nvSpPr>
-        <p:spPr/>
-        <p:txBody>
-          <a:bodyPr/>
-          <a:lstStyle/>
-          <a:p>
-            <a:fld id="{F7021451-1387-4CA6-816F-3879F97B5CBC}" type="slidenum">
-              <a:rPr lang="en-US"/>
-              <a:t>9</a:t>
             </a:fld>
             <a:endParaRPr lang="en-US"/>
           </a:p>
@@ -1835,123 +1395,6 @@
 <file path=ppt/slides/slide1.xml><?xml version="1.0" encoding="utf-8"?>
 <p:sld xmlns:a="http://schemas.openxmlformats.org/drawingml/2006/main" xmlns:r="http://schemas.openxmlformats.org/officeDocument/2006/relationships" xmlns:p="http://schemas.openxmlformats.org/presentationml/2006/main">
   <p:cSld name="Slide 1">
-    <p:bg>
-      <p:bgPr>
-        <a:blipFill dpi="0" rotWithShape="1">
-          <a:blip r:embed="rId1">
-            <a:lum/>
-          </a:blip>
-          <a:srcRect/>
-          <a:stretch>
-            <a:fillRect/>
-          </a:stretch>
-        </a:blipFill>
-        <a:effectLst/>
-      </p:bgPr>
-    </p:bg>
-    <p:spTree>
-      <p:nvGrpSpPr>
-        <p:cNvPr id="1" name=""/>
-        <p:cNvGrpSpPr/>
-        <p:nvPr/>
-      </p:nvGrpSpPr>
-      <p:grpSpPr>
-        <a:xfrm>
-          <a:off x="0" y="0"/>
-          <a:ext cx="0" cy="0"/>
-          <a:chOff x="0" y="0"/>
-          <a:chExt cx="0" cy="0"/>
-        </a:xfrm>
-      </p:grpSpPr>
-    </p:spTree>
-  </p:cSld>
-  <p:clrMapOvr>
-    <a:masterClrMapping/>
-  </p:clrMapOvr>
-</p:sld>
-</file>
-
-<file path=ppt/slides/slide10.xml><?xml version="1.0" encoding="utf-8"?>
-<p:sld xmlns:a="http://schemas.openxmlformats.org/drawingml/2006/main" xmlns:r="http://schemas.openxmlformats.org/officeDocument/2006/relationships" xmlns:p="http://schemas.openxmlformats.org/presentationml/2006/main">
-  <p:cSld name="Slide 10">
-    <p:bg>
-      <p:bgPr>
-        <a:blipFill dpi="0" rotWithShape="1">
-          <a:blip r:embed="rId1">
-            <a:lum/>
-          </a:blip>
-          <a:srcRect/>
-          <a:stretch>
-            <a:fillRect/>
-          </a:stretch>
-        </a:blipFill>
-        <a:effectLst/>
-      </p:bgPr>
-    </p:bg>
-    <p:spTree>
-      <p:nvGrpSpPr>
-        <p:cNvPr id="1" name=""/>
-        <p:cNvGrpSpPr/>
-        <p:nvPr/>
-      </p:nvGrpSpPr>
-      <p:grpSpPr>
-        <a:xfrm>
-          <a:off x="0" y="0"/>
-          <a:ext cx="0" cy="0"/>
-          <a:chOff x="0" y="0"/>
-          <a:chExt cx="0" cy="0"/>
-        </a:xfrm>
-      </p:grpSpPr>
-    </p:spTree>
-  </p:cSld>
-  <p:clrMapOvr>
-    <a:masterClrMapping/>
-  </p:clrMapOvr>
-</p:sld>
-</file>
-
-<file path=ppt/slides/slide11.xml><?xml version="1.0" encoding="utf-8"?>
-<p:sld xmlns:a="http://schemas.openxmlformats.org/drawingml/2006/main" xmlns:r="http://schemas.openxmlformats.org/officeDocument/2006/relationships" xmlns:p="http://schemas.openxmlformats.org/presentationml/2006/main">
-  <p:cSld name="Slide 11">
-    <p:bg>
-      <p:bgPr>
-        <a:blipFill dpi="0" rotWithShape="1">
-          <a:blip r:embed="rId1">
-            <a:lum/>
-          </a:blip>
-          <a:srcRect/>
-          <a:stretch>
-            <a:fillRect/>
-          </a:stretch>
-        </a:blipFill>
-        <a:effectLst/>
-      </p:bgPr>
-    </p:bg>
-    <p:spTree>
-      <p:nvGrpSpPr>
-        <p:cNvPr id="1" name=""/>
-        <p:cNvGrpSpPr/>
-        <p:nvPr/>
-      </p:nvGrpSpPr>
-      <p:grpSpPr>
-        <a:xfrm>
-          <a:off x="0" y="0"/>
-          <a:ext cx="0" cy="0"/>
-          <a:chOff x="0" y="0"/>
-          <a:chExt cx="0" cy="0"/>
-        </a:xfrm>
-      </p:grpSpPr>
-    </p:spTree>
-  </p:cSld>
-  <p:clrMapOvr>
-    <a:masterClrMapping/>
-  </p:clrMapOvr>
-</p:sld>
-</file>
-
-<file path=ppt/slides/slide12.xml><?xml version="1.0" encoding="utf-8"?>
-<p:sld xmlns:a="http://schemas.openxmlformats.org/drawingml/2006/main" xmlns:r="http://schemas.openxmlformats.org/officeDocument/2006/relationships" xmlns:p="http://schemas.openxmlformats.org/presentationml/2006/main">
-  <p:cSld name="Slide 12">
     <p:bg>
       <p:bgPr>
         <a:blipFill dpi="0" rotWithShape="1">
@@ -2222,84 +1665,6 @@
 </p:sld>
 </file>
 
-<file path=ppt/slides/slide8.xml><?xml version="1.0" encoding="utf-8"?>
-<p:sld xmlns:a="http://schemas.openxmlformats.org/drawingml/2006/main" xmlns:r="http://schemas.openxmlformats.org/officeDocument/2006/relationships" xmlns:p="http://schemas.openxmlformats.org/presentationml/2006/main">
-  <p:cSld name="Slide 8">
-    <p:bg>
-      <p:bgPr>
-        <a:blipFill dpi="0" rotWithShape="1">
-          <a:blip r:embed="rId1">
-            <a:lum/>
-          </a:blip>
-          <a:srcRect/>
-          <a:stretch>
-            <a:fillRect/>
-          </a:stretch>
-        </a:blipFill>
-        <a:effectLst/>
-      </p:bgPr>
-    </p:bg>
-    <p:spTree>
-      <p:nvGrpSpPr>
-        <p:cNvPr id="1" name=""/>
-        <p:cNvGrpSpPr/>
-        <p:nvPr/>
-      </p:nvGrpSpPr>
-      <p:grpSpPr>
-        <a:xfrm>
-          <a:off x="0" y="0"/>
-          <a:ext cx="0" cy="0"/>
-          <a:chOff x="0" y="0"/>
-          <a:chExt cx="0" cy="0"/>
-        </a:xfrm>
-      </p:grpSpPr>
-    </p:spTree>
-  </p:cSld>
-  <p:clrMapOvr>
-    <a:masterClrMapping/>
-  </p:clrMapOvr>
-</p:sld>
-</file>
-
-<file path=ppt/slides/slide9.xml><?xml version="1.0" encoding="utf-8"?>
-<p:sld xmlns:a="http://schemas.openxmlformats.org/drawingml/2006/main" xmlns:r="http://schemas.openxmlformats.org/officeDocument/2006/relationships" xmlns:p="http://schemas.openxmlformats.org/presentationml/2006/main">
-  <p:cSld name="Slide 9">
-    <p:bg>
-      <p:bgPr>
-        <a:blipFill dpi="0" rotWithShape="1">
-          <a:blip r:embed="rId1">
-            <a:lum/>
-          </a:blip>
-          <a:srcRect/>
-          <a:stretch>
-            <a:fillRect/>
-          </a:stretch>
-        </a:blipFill>
-        <a:effectLst/>
-      </p:bgPr>
-    </p:bg>
-    <p:spTree>
-      <p:nvGrpSpPr>
-        <p:cNvPr id="1" name=""/>
-        <p:cNvGrpSpPr/>
-        <p:nvPr/>
-      </p:nvGrpSpPr>
-      <p:grpSpPr>
-        <a:xfrm>
-          <a:off x="0" y="0"/>
-          <a:ext cx="0" cy="0"/>
-          <a:chOff x="0" y="0"/>
-          <a:chExt cx="0" cy="0"/>
-        </a:xfrm>
-      </p:grpSpPr>
-    </p:spTree>
-  </p:cSld>
-  <p:clrMapOvr>
-    <a:masterClrMapping/>
-  </p:clrMapOvr>
-</p:sld>
-</file>
-
 <file path=ppt/theme/theme1.xml><?xml version="1.0" encoding="utf-8"?>
 <a:theme xmlns:a="http://schemas.openxmlformats.org/drawingml/2006/main" name="Office Theme">
   <a:themeElements>

</xml_diff>